<commit_message>
while 문 ppt, 코드 추가
</commit_message>
<xml_diff>
--- a/material/2_Python/09_2_반복문_while.pptx
+++ b/material/2_Python/09_2_반복문_while.pptx
@@ -5,7 +5,7 @@
     <p:sldMasterId id="2147483660" r:id="rId1"/>
   </p:sldMasterIdLst>
   <p:notesMasterIdLst>
-    <p:notesMasterId r:id="rId28"/>
+    <p:notesMasterId r:id="rId29"/>
   </p:notesMasterIdLst>
   <p:sldIdLst>
     <p:sldId id="1048" r:id="rId2"/>
@@ -33,39 +33,40 @@
     <p:sldId id="1171" r:id="rId24"/>
     <p:sldId id="1172" r:id="rId25"/>
     <p:sldId id="1185" r:id="rId26"/>
-    <p:sldId id="813" r:id="rId27"/>
+    <p:sldId id="1186" r:id="rId27"/>
+    <p:sldId id="813" r:id="rId28"/>
   </p:sldIdLst>
   <p:sldSz cx="12192000" cy="6858000"/>
   <p:notesSz cx="6858000" cy="9144000"/>
   <p:embeddedFontLst>
     <p:embeddedFont>
-      <p:font typeface="Kim jung chul Gothic Regular" panose="020B0503000000000000" pitchFamily="50" charset="-127"/>
-      <p:regular r:id="rId29"/>
-    </p:embeddedFont>
-    <p:embeddedFont>
-      <p:font typeface="G마켓 산스 TTF Bold" panose="02000000000000000000" pitchFamily="2" charset="-127"/>
-      <p:bold r:id="rId30"/>
+      <p:font typeface="Kim jung chul Gothic Regular" panose="020B0600000101010101" charset="-127"/>
+      <p:regular r:id="rId30"/>
     </p:embeddedFont>
     <p:embeddedFont>
       <p:font typeface="Malgun Gothic Semilight" panose="020B0502040204020203" pitchFamily="50" charset="-127"/>
       <p:regular r:id="rId31"/>
     </p:embeddedFont>
     <p:embeddedFont>
-      <p:font typeface="Pretendard Black" panose="02000A03000000020004" pitchFamily="2" charset="-127"/>
-      <p:bold r:id="rId32"/>
+      <p:font typeface="메이플스토리" panose="020B0600000101010101" charset="-127"/>
+      <p:regular r:id="rId32"/>
+      <p:bold r:id="rId33"/>
     </p:embeddedFont>
     <p:embeddedFont>
-      <p:font typeface="Pretendard Light" panose="02000403000000020004" pitchFamily="2" charset="-127"/>
-      <p:regular r:id="rId33"/>
+      <p:font typeface="G마켓 산스 TTF Bold" panose="02000000000000000000" pitchFamily="2" charset="-127"/>
+      <p:bold r:id="rId34"/>
     </p:embeddedFont>
     <p:embeddedFont>
-      <p:font typeface="Pretendard Medium" panose="02000603000000020004" pitchFamily="2" charset="-127"/>
-      <p:regular r:id="rId34"/>
+      <p:font typeface="Pretendard Black" panose="02000A03000000020004" pitchFamily="50" charset="-127"/>
+      <p:bold r:id="rId35"/>
     </p:embeddedFont>
     <p:embeddedFont>
-      <p:font typeface="메이플스토리" panose="02000300000000000000" pitchFamily="2" charset="-127"/>
-      <p:regular r:id="rId35"/>
-      <p:bold r:id="rId36"/>
+      <p:font typeface="Pretendard Light" panose="02000403000000020004" pitchFamily="50" charset="-127"/>
+      <p:regular r:id="rId36"/>
+    </p:embeddedFont>
+    <p:embeddedFont>
+      <p:font typeface="Pretendard Medium" panose="02000603000000020004" pitchFamily="50" charset="-127"/>
+      <p:regular r:id="rId37"/>
     </p:embeddedFont>
   </p:embeddedFontLst>
   <p:defaultTextStyle>
@@ -274,7 +275,7 @@
             <a:fld id="{A13A867C-D490-40C2-AB8D-A60FA70A9BF5}" type="datetimeFigureOut">
               <a:rPr lang="ko-KR" altLang="en-US" smtClean="0"/>
               <a:pPr/>
-              <a:t>2025-09-01</a:t>
+              <a:t>2025-11-19</a:t>
             </a:fld>
             <a:endParaRPr lang="ko-KR" altLang="en-US" dirty="0"/>
           </a:p>
@@ -1961,6 +1962,114 @@
         <p:cNvPr id="1" name="">
           <a:extLst>
             <a:ext uri="{FF2B5EF4-FFF2-40B4-BE49-F238E27FC236}">
+              <a16:creationId xmlns:a16="http://schemas.microsoft.com/office/drawing/2014/main" id="{D2BA9424-4BA2-2202-EA72-322233A3C64F}"/>
+            </a:ext>
+          </a:extLst>
+        </p:cNvPr>
+        <p:cNvGrpSpPr/>
+        <p:nvPr/>
+      </p:nvGrpSpPr>
+      <p:grpSpPr>
+        <a:xfrm>
+          <a:off x="0" y="0"/>
+          <a:ext cx="0" cy="0"/>
+          <a:chOff x="0" y="0"/>
+          <a:chExt cx="0" cy="0"/>
+        </a:xfrm>
+      </p:grpSpPr>
+      <p:sp>
+        <p:nvSpPr>
+          <p:cNvPr id="2" name="슬라이드 이미지 개체 틀 1">
+            <a:extLst>
+              <a:ext uri="{FF2B5EF4-FFF2-40B4-BE49-F238E27FC236}">
+                <a16:creationId xmlns:a16="http://schemas.microsoft.com/office/drawing/2014/main" id="{F9ABB599-D1BC-9379-3C48-50D46D1A6327}"/>
+              </a:ext>
+            </a:extLst>
+          </p:cNvPr>
+          <p:cNvSpPr>
+            <a:spLocks noGrp="1" noRot="1" noChangeAspect="1"/>
+          </p:cNvSpPr>
+          <p:nvPr>
+            <p:ph type="sldImg"/>
+          </p:nvPr>
+        </p:nvSpPr>
+        <p:spPr/>
+      </p:sp>
+      <p:sp>
+        <p:nvSpPr>
+          <p:cNvPr id="3" name="슬라이드 노트 개체 틀 2">
+            <a:extLst>
+              <a:ext uri="{FF2B5EF4-FFF2-40B4-BE49-F238E27FC236}">
+                <a16:creationId xmlns:a16="http://schemas.microsoft.com/office/drawing/2014/main" id="{C0854CE0-5186-D862-F491-1CA6BC53E007}"/>
+              </a:ext>
+            </a:extLst>
+          </p:cNvPr>
+          <p:cNvSpPr>
+            <a:spLocks noGrp="1"/>
+          </p:cNvSpPr>
+          <p:nvPr>
+            <p:ph type="body" idx="1"/>
+          </p:nvPr>
+        </p:nvSpPr>
+        <p:spPr/>
+        <p:txBody>
+          <a:bodyPr/>
+          <a:lstStyle/>
+          <a:p>
+            <a:endParaRPr lang="ko-KR" altLang="en-US" dirty="0"/>
+          </a:p>
+        </p:txBody>
+      </p:sp>
+      <p:sp>
+        <p:nvSpPr>
+          <p:cNvPr id="4" name="슬라이드 번호 개체 틀 3">
+            <a:extLst>
+              <a:ext uri="{FF2B5EF4-FFF2-40B4-BE49-F238E27FC236}">
+                <a16:creationId xmlns:a16="http://schemas.microsoft.com/office/drawing/2014/main" id="{75BBC0F8-4C07-2E59-7D13-6CB81585591D}"/>
+              </a:ext>
+            </a:extLst>
+          </p:cNvPr>
+          <p:cNvSpPr>
+            <a:spLocks noGrp="1"/>
+          </p:cNvSpPr>
+          <p:nvPr>
+            <p:ph type="sldNum" sz="quarter" idx="5"/>
+          </p:nvPr>
+        </p:nvSpPr>
+        <p:spPr/>
+        <p:txBody>
+          <a:bodyPr/>
+          <a:lstStyle/>
+          <a:p>
+            <a:fld id="{C09E5BFC-1559-42F1-8940-AB342D56BF02}" type="slidenum">
+              <a:rPr lang="ko-KR" altLang="en-US" smtClean="0"/>
+              <a:t>26</a:t>
+            </a:fld>
+            <a:endParaRPr lang="ko-KR" altLang="en-US"/>
+          </a:p>
+        </p:txBody>
+      </p:sp>
+    </p:spTree>
+    <p:extLst>
+      <p:ext uri="{BB962C8B-B14F-4D97-AF65-F5344CB8AC3E}">
+        <p14:creationId xmlns:p14="http://schemas.microsoft.com/office/powerpoint/2010/main" val="1923018415"/>
+      </p:ext>
+    </p:extLst>
+  </p:cSld>
+  <p:clrMapOvr>
+    <a:masterClrMapping/>
+  </p:clrMapOvr>
+</p:notes>
+</file>
+
+<file path=ppt/notesSlides/notesSlide22.xml><?xml version="1.0" encoding="utf-8"?>
+<p:notes xmlns:a="http://schemas.openxmlformats.org/drawingml/2006/main" xmlns:r="http://schemas.openxmlformats.org/officeDocument/2006/relationships" xmlns:p="http://schemas.openxmlformats.org/presentationml/2006/main">
+  <p:cSld>
+    <p:spTree>
+      <p:nvGrpSpPr>
+        <p:cNvPr id="1" name="">
+          <a:extLst>
+            <a:ext uri="{FF2B5EF4-FFF2-40B4-BE49-F238E27FC236}">
               <a16:creationId xmlns:a16="http://schemas.microsoft.com/office/drawing/2014/main" id="{827DCA84-D834-7EED-20D1-8EA7A0219FFB}"/>
             </a:ext>
           </a:extLst>
@@ -2042,7 +2151,7 @@
           <a:p>
             <a:fld id="{A0085365-8376-4996-BDD6-F39608FADAF3}" type="slidenum">
               <a:rPr lang="ko-KR" altLang="en-US" smtClean="0"/>
-              <a:t>26</a:t>
+              <a:t>27</a:t>
             </a:fld>
             <a:endParaRPr lang="ko-KR" altLang="en-US"/>
           </a:p>
@@ -2970,7 +3079,7 @@
           <a:p>
             <a:fld id="{442BEE3F-2E9A-4FD8-8B8A-8619F3E161C0}" type="datetime1">
               <a:rPr lang="ko-KR" altLang="en-US" smtClean="0"/>
-              <a:t>2025-09-01</a:t>
+              <a:t>2025-11-19</a:t>
             </a:fld>
             <a:endParaRPr lang="ko-KR" altLang="en-US"/>
           </a:p>
@@ -3257,7 +3366,7 @@
           <a:p>
             <a:fld id="{0F78D9C4-20C1-4B15-A116-16DC77AD9A1E}" type="datetime1">
               <a:rPr lang="ko-KR" altLang="en-US" smtClean="0"/>
-              <a:t>2025-09-01</a:t>
+              <a:t>2025-11-19</a:t>
             </a:fld>
             <a:endParaRPr lang="ko-KR" altLang="en-US"/>
           </a:p>
@@ -3432,7 +3541,7 @@
           <a:p>
             <a:fld id="{7F5E23C3-0E3D-4E4E-8486-D7FB4C073DC1}" type="datetime1">
               <a:rPr lang="ko-KR" altLang="en-US" smtClean="0"/>
-              <a:t>2025-09-01</a:t>
+              <a:t>2025-11-19</a:t>
             </a:fld>
             <a:endParaRPr lang="ko-KR" altLang="en-US"/>
           </a:p>
@@ -3761,7 +3870,7 @@
           <a:p>
             <a:fld id="{7F5E23C3-0E3D-4E4E-8486-D7FB4C073DC1}" type="datetime1">
               <a:rPr lang="ko-KR" altLang="en-US" smtClean="0"/>
-              <a:t>2025-09-01</a:t>
+              <a:t>2025-11-19</a:t>
             </a:fld>
             <a:endParaRPr lang="ko-KR" altLang="en-US"/>
           </a:p>
@@ -4765,7 +4874,7 @@
           <a:p>
             <a:fld id="{0F78D9C4-20C1-4B15-A116-16DC77AD9A1E}" type="datetime1">
               <a:rPr lang="ko-KR" altLang="en-US" smtClean="0"/>
-              <a:t>2025-09-01</a:t>
+              <a:t>2025-11-19</a:t>
             </a:fld>
             <a:endParaRPr lang="ko-KR" altLang="en-US" dirty="0"/>
           </a:p>
@@ -5177,7 +5286,7 @@
           <a:p>
             <a:fld id="{0F78D9C4-20C1-4B15-A116-16DC77AD9A1E}" type="datetime1">
               <a:rPr lang="ko-KR" altLang="en-US" smtClean="0"/>
-              <a:t>2025-09-01</a:t>
+              <a:t>2025-11-19</a:t>
             </a:fld>
             <a:endParaRPr lang="ko-KR" altLang="en-US" dirty="0"/>
           </a:p>
@@ -5730,7 +5839,7 @@
           <a:p>
             <a:fld id="{76022175-F16A-4A96-8E45-178BE9345AE9}" type="datetime6">
               <a:rPr lang="ko-KR" altLang="en-US" smtClean="0"/>
-              <a:t>2025년 9월</a:t>
+              <a:t>2025년 11월</a:t>
             </a:fld>
             <a:endParaRPr lang="ko-KR" altLang="en-US"/>
           </a:p>
@@ -6256,7 +6365,7 @@
           <a:p>
             <a:fld id="{76022175-F16A-4A96-8E45-178BE9345AE9}" type="datetime6">
               <a:rPr lang="ko-KR" altLang="en-US" smtClean="0"/>
-              <a:t>2025년 9월</a:t>
+              <a:t>2025년 11월</a:t>
             </a:fld>
             <a:endParaRPr lang="ko-KR" altLang="en-US"/>
           </a:p>
@@ -6572,7 +6681,7 @@
           <a:p>
             <a:fld id="{0F78D9C4-20C1-4B15-A116-16DC77AD9A1E}" type="datetime1">
               <a:rPr lang="ko-KR" altLang="en-US" smtClean="0"/>
-              <a:t>2025-09-01</a:t>
+              <a:t>2025-11-19</a:t>
             </a:fld>
             <a:endParaRPr lang="ko-KR" altLang="en-US" dirty="0"/>
           </a:p>
@@ -7071,7 +7180,7 @@
           <a:p>
             <a:fld id="{0F78D9C4-20C1-4B15-A116-16DC77AD9A1E}" type="datetime1">
               <a:rPr lang="ko-KR" altLang="en-US" smtClean="0"/>
-              <a:t>2025-09-01</a:t>
+              <a:t>2025-11-19</a:t>
             </a:fld>
             <a:endParaRPr lang="ko-KR" altLang="en-US" dirty="0"/>
           </a:p>
@@ -7409,7 +7518,7 @@
           <a:p>
             <a:fld id="{0F78D9C4-20C1-4B15-A116-16DC77AD9A1E}" type="datetime1">
               <a:rPr lang="ko-KR" altLang="en-US" smtClean="0"/>
-              <a:t>2025-09-01</a:t>
+              <a:t>2025-11-19</a:t>
             </a:fld>
             <a:endParaRPr lang="ko-KR" altLang="en-US" dirty="0"/>
           </a:p>
@@ -7670,7 +7779,7 @@
           <a:p>
             <a:fld id="{0F78D9C4-20C1-4B15-A116-16DC77AD9A1E}" type="datetime1">
               <a:rPr lang="ko-KR" altLang="en-US" smtClean="0"/>
-              <a:t>2025-09-01</a:t>
+              <a:t>2025-11-19</a:t>
             </a:fld>
             <a:endParaRPr lang="ko-KR" altLang="en-US" dirty="0"/>
           </a:p>
@@ -8007,7 +8116,7 @@
           <a:p>
             <a:fld id="{0F78D9C4-20C1-4B15-A116-16DC77AD9A1E}" type="datetime1">
               <a:rPr lang="ko-KR" altLang="en-US" smtClean="0"/>
-              <a:t>2025-09-01</a:t>
+              <a:t>2025-11-19</a:t>
             </a:fld>
             <a:endParaRPr lang="ko-KR" altLang="en-US" dirty="0"/>
           </a:p>
@@ -8851,7 +8960,7 @@
           <a:p>
             <a:fld id="{76022175-F16A-4A96-8E45-178BE9345AE9}" type="datetime6">
               <a:rPr lang="ko-KR" altLang="en-US" smtClean="0"/>
-              <a:t>2025년 9월</a:t>
+              <a:t>2025년 11월</a:t>
             </a:fld>
             <a:endParaRPr lang="ko-KR" altLang="en-US"/>
           </a:p>
@@ -9374,7 +9483,7 @@
           <a:p>
             <a:fld id="{76022175-F16A-4A96-8E45-178BE9345AE9}" type="datetime6">
               <a:rPr lang="ko-KR" altLang="en-US" smtClean="0"/>
-              <a:t>2025년 9월</a:t>
+              <a:t>2025년 11월</a:t>
             </a:fld>
             <a:endParaRPr lang="ko-KR" altLang="en-US"/>
           </a:p>
@@ -9762,7 +9871,7 @@
           <a:p>
             <a:fld id="{0F78D9C4-20C1-4B15-A116-16DC77AD9A1E}" type="datetime1">
               <a:rPr lang="ko-KR" altLang="en-US" smtClean="0"/>
-              <a:t>2025-09-01</a:t>
+              <a:t>2025-11-19</a:t>
             </a:fld>
             <a:endParaRPr lang="ko-KR" altLang="en-US" dirty="0"/>
           </a:p>
@@ -10188,7 +10297,7 @@
           <a:p>
             <a:fld id="{0F78D9C4-20C1-4B15-A116-16DC77AD9A1E}" type="datetime1">
               <a:rPr lang="ko-KR" altLang="en-US" smtClean="0"/>
-              <a:t>2025-09-01</a:t>
+              <a:t>2025-11-19</a:t>
             </a:fld>
             <a:endParaRPr lang="ko-KR" altLang="en-US" dirty="0"/>
           </a:p>
@@ -10816,7 +10925,7 @@
           <a:p>
             <a:fld id="{76022175-F16A-4A96-8E45-178BE9345AE9}" type="datetime6">
               <a:rPr lang="ko-KR" altLang="en-US" smtClean="0"/>
-              <a:t>2025년 9월</a:t>
+              <a:t>2025년 11월</a:t>
             </a:fld>
             <a:endParaRPr lang="ko-KR" altLang="en-US"/>
           </a:p>
@@ -10955,6 +11064,474 @@
 </file>
 
 <file path=ppt/slides/slide26.xml><?xml version="1.0" encoding="utf-8"?>
+<p:sld xmlns:a="http://schemas.openxmlformats.org/drawingml/2006/main" xmlns:r="http://schemas.openxmlformats.org/officeDocument/2006/relationships" xmlns:p="http://schemas.openxmlformats.org/presentationml/2006/main">
+  <p:cSld>
+    <p:spTree>
+      <p:nvGrpSpPr>
+        <p:cNvPr id="1" name="">
+          <a:extLst>
+            <a:ext uri="{FF2B5EF4-FFF2-40B4-BE49-F238E27FC236}">
+              <a16:creationId xmlns:a16="http://schemas.microsoft.com/office/drawing/2014/main" id="{8F7D369C-373E-9EAA-54C4-B9D6CE637520}"/>
+            </a:ext>
+          </a:extLst>
+        </p:cNvPr>
+        <p:cNvGrpSpPr/>
+        <p:nvPr/>
+      </p:nvGrpSpPr>
+      <p:grpSpPr>
+        <a:xfrm>
+          <a:off x="0" y="0"/>
+          <a:ext cx="0" cy="0"/>
+          <a:chOff x="0" y="0"/>
+          <a:chExt cx="0" cy="0"/>
+        </a:xfrm>
+      </p:grpSpPr>
+      <p:sp>
+        <p:nvSpPr>
+          <p:cNvPr id="8" name="내용 개체 틀 7">
+            <a:extLst>
+              <a:ext uri="{FF2B5EF4-FFF2-40B4-BE49-F238E27FC236}">
+                <a16:creationId xmlns:a16="http://schemas.microsoft.com/office/drawing/2014/main" id="{76702E1A-B6ED-5D26-8685-4CEE2F3A0105}"/>
+              </a:ext>
+            </a:extLst>
+          </p:cNvPr>
+          <p:cNvSpPr>
+            <a:spLocks noGrp="1"/>
+          </p:cNvSpPr>
+          <p:nvPr>
+            <p:ph idx="1"/>
+          </p:nvPr>
+        </p:nvSpPr>
+        <p:spPr>
+          <a:xfrm>
+            <a:off x="251788" y="1145405"/>
+            <a:ext cx="11641762" cy="5017889"/>
+          </a:xfrm>
+        </p:spPr>
+        <p:txBody>
+          <a:bodyPr>
+            <a:noAutofit/>
+          </a:bodyPr>
+          <a:lstStyle/>
+          <a:p>
+            <a:pPr marL="0" indent="0">
+              <a:lnSpc>
+                <a:spcPct val="150000"/>
+              </a:lnSpc>
+              <a:buNone/>
+            </a:pPr>
+            <a:r>
+              <a:rPr lang="ko-KR" altLang="en-US" sz="2400" dirty="0">
+                <a:latin typeface="Pretendard Medium" panose="02000603000000020004" pitchFamily="50" charset="-127"/>
+                <a:ea typeface="Pretendard Medium" panose="02000603000000020004" pitchFamily="50" charset="-127"/>
+                <a:cs typeface="Pretendard Medium" panose="02000603000000020004" pitchFamily="50" charset="-127"/>
+              </a:rPr>
+              <a:t>📌추가 문제</a:t>
+            </a:r>
+            <a:r>
+              <a:rPr lang="en-US" altLang="ko-KR" sz="2400" dirty="0">
+                <a:latin typeface="Pretendard Medium" panose="02000603000000020004" pitchFamily="50" charset="-127"/>
+                <a:ea typeface="Pretendard Medium" panose="02000603000000020004" pitchFamily="50" charset="-127"/>
+                <a:cs typeface="Pretendard Medium" panose="02000603000000020004" pitchFamily="50" charset="-127"/>
+              </a:rPr>
+              <a:t>. </a:t>
+            </a:r>
+            <a:r>
+              <a:rPr lang="ko-KR" altLang="en-US" sz="2400" dirty="0"/>
+              <a:t>로그인 시스템 구현</a:t>
+            </a:r>
+            <a:endParaRPr lang="ko-KR" altLang="en-US" sz="2400" dirty="0">
+              <a:latin typeface="Pretendard Medium" panose="02000603000000020004" pitchFamily="50" charset="-127"/>
+              <a:ea typeface="Pretendard Medium" panose="02000603000000020004" pitchFamily="50" charset="-127"/>
+              <a:cs typeface="Pretendard Medium" panose="02000603000000020004" pitchFamily="50" charset="-127"/>
+            </a:endParaRPr>
+          </a:p>
+          <a:p>
+            <a:pPr marL="0" indent="0">
+              <a:buNone/>
+            </a:pPr>
+            <a:endParaRPr lang="en-US" altLang="ko-KR" sz="2000" dirty="0">
+              <a:latin typeface="Pretendard Light" panose="02000403000000020004" pitchFamily="2" charset="-127"/>
+              <a:ea typeface="Pretendard Light" panose="02000403000000020004" pitchFamily="2" charset="-127"/>
+              <a:cs typeface="Pretendard Light" panose="02000403000000020004" pitchFamily="2" charset="-127"/>
+            </a:endParaRPr>
+          </a:p>
+          <a:p>
+            <a:pPr marL="0" indent="0">
+              <a:buNone/>
+            </a:pPr>
+            <a:r>
+              <a:rPr lang="ko-KR" altLang="en-US" sz="2000" dirty="0">
+                <a:latin typeface="Pretendard Light" panose="02000403000000020004" pitchFamily="2" charset="-127"/>
+                <a:ea typeface="Pretendard Light" panose="02000403000000020004" pitchFamily="2" charset="-127"/>
+                <a:cs typeface="Pretendard Light" panose="02000403000000020004" pitchFamily="2" charset="-127"/>
+              </a:rPr>
+              <a:t>✅ 조건</a:t>
+            </a:r>
+            <a:endParaRPr lang="en-US" altLang="ko-KR" sz="2000" dirty="0">
+              <a:latin typeface="Pretendard Light" panose="02000403000000020004" pitchFamily="2" charset="-127"/>
+              <a:ea typeface="Pretendard Light" panose="02000403000000020004" pitchFamily="2" charset="-127"/>
+              <a:cs typeface="Pretendard Light" panose="02000403000000020004" pitchFamily="2" charset="-127"/>
+            </a:endParaRPr>
+          </a:p>
+          <a:p>
+            <a:r>
+              <a:rPr lang="ko-KR" altLang="en-US" sz="2000" dirty="0">
+                <a:latin typeface="Pretendard Light" panose="02000403000000020004" pitchFamily="2" charset="-127"/>
+                <a:ea typeface="Pretendard Light" panose="02000403000000020004" pitchFamily="2" charset="-127"/>
+                <a:cs typeface="Pretendard Light" panose="02000403000000020004" pitchFamily="2" charset="-127"/>
+              </a:rPr>
+              <a:t>임의의 </a:t>
+            </a:r>
+            <a:r>
+              <a:rPr lang="en-US" altLang="ko-KR" sz="2000" dirty="0">
+                <a:latin typeface="Pretendard Light" panose="02000403000000020004" pitchFamily="2" charset="-127"/>
+                <a:ea typeface="Pretendard Light" panose="02000403000000020004" pitchFamily="2" charset="-127"/>
+                <a:cs typeface="Pretendard Light" panose="02000403000000020004" pitchFamily="2" charset="-127"/>
+              </a:rPr>
+              <a:t>ID</a:t>
+            </a:r>
+            <a:r>
+              <a:rPr lang="ko-KR" altLang="en-US" sz="2000" dirty="0">
+                <a:latin typeface="Pretendard Light" panose="02000403000000020004" pitchFamily="2" charset="-127"/>
+                <a:ea typeface="Pretendard Light" panose="02000403000000020004" pitchFamily="2" charset="-127"/>
+                <a:cs typeface="Pretendard Light" panose="02000403000000020004" pitchFamily="2" charset="-127"/>
+              </a:rPr>
+              <a:t>와</a:t>
+            </a:r>
+            <a:r>
+              <a:rPr lang="en-US" altLang="ko-KR" sz="2000" dirty="0">
+                <a:latin typeface="Pretendard Light" panose="02000403000000020004" pitchFamily="2" charset="-127"/>
+                <a:ea typeface="Pretendard Light" panose="02000403000000020004" pitchFamily="2" charset="-127"/>
+                <a:cs typeface="Pretendard Light" panose="02000403000000020004" pitchFamily="2" charset="-127"/>
+              </a:rPr>
+              <a:t> </a:t>
+            </a:r>
+            <a:r>
+              <a:rPr lang="ko-KR" altLang="en-US" sz="2000" dirty="0">
+                <a:latin typeface="Pretendard Light" panose="02000403000000020004" pitchFamily="2" charset="-127"/>
+                <a:ea typeface="Pretendard Light" panose="02000403000000020004" pitchFamily="2" charset="-127"/>
+                <a:cs typeface="Pretendard Light" panose="02000403000000020004" pitchFamily="2" charset="-127"/>
+              </a:rPr>
+              <a:t>비밀번호를 세팅합니다</a:t>
+            </a:r>
+            <a:r>
+              <a:rPr lang="en-US" altLang="ko-KR" sz="2000" dirty="0">
+                <a:latin typeface="Pretendard Light" panose="02000403000000020004" pitchFamily="2" charset="-127"/>
+                <a:ea typeface="Pretendard Light" panose="02000403000000020004" pitchFamily="2" charset="-127"/>
+                <a:cs typeface="Pretendard Light" panose="02000403000000020004" pitchFamily="2" charset="-127"/>
+              </a:rPr>
+              <a:t>.</a:t>
+            </a:r>
+          </a:p>
+          <a:p>
+            <a:r>
+              <a:rPr lang="ko-KR" altLang="en-US" sz="2000" dirty="0">
+                <a:latin typeface="Pretendard Light" panose="02000403000000020004" pitchFamily="2" charset="-127"/>
+                <a:ea typeface="Pretendard Light" panose="02000403000000020004" pitchFamily="2" charset="-127"/>
+                <a:cs typeface="Pretendard Light" panose="02000403000000020004" pitchFamily="2" charset="-127"/>
+              </a:rPr>
+              <a:t>중첩 </a:t>
+            </a:r>
+            <a:r>
+              <a:rPr lang="en-US" altLang="ko-KR" sz="2000" dirty="0">
+                <a:latin typeface="Pretendard Light" panose="02000403000000020004" pitchFamily="2" charset="-127"/>
+                <a:ea typeface="Pretendard Light" panose="02000403000000020004" pitchFamily="2" charset="-127"/>
+                <a:cs typeface="Pretendard Light" panose="02000403000000020004" pitchFamily="2" charset="-127"/>
+              </a:rPr>
+              <a:t>while</a:t>
+            </a:r>
+            <a:r>
+              <a:rPr lang="ko-KR" altLang="en-US" sz="2000" dirty="0">
+                <a:latin typeface="Pretendard Light" panose="02000403000000020004" pitchFamily="2" charset="-127"/>
+                <a:ea typeface="Pretendard Light" panose="02000403000000020004" pitchFamily="2" charset="-127"/>
+                <a:cs typeface="Pretendard Light" panose="02000403000000020004" pitchFamily="2" charset="-127"/>
+              </a:rPr>
+              <a:t>문 사용</a:t>
+            </a:r>
+            <a:endParaRPr lang="en-US" altLang="ko-KR" sz="2000" dirty="0">
+              <a:latin typeface="Pretendard Light" panose="02000403000000020004" pitchFamily="2" charset="-127"/>
+              <a:ea typeface="Pretendard Light" panose="02000403000000020004" pitchFamily="2" charset="-127"/>
+              <a:cs typeface="Pretendard Light" panose="02000403000000020004" pitchFamily="2" charset="-127"/>
+            </a:endParaRPr>
+          </a:p>
+          <a:p>
+            <a:r>
+              <a:rPr lang="en-US" altLang="ko-KR" sz="2000" dirty="0" err="1">
+                <a:latin typeface="Pretendard Light" panose="02000403000000020004" pitchFamily="2" charset="-127"/>
+                <a:ea typeface="Pretendard Light" panose="02000403000000020004" pitchFamily="2" charset="-127"/>
+                <a:cs typeface="Pretendard Light" panose="02000403000000020004" pitchFamily="2" charset="-127"/>
+              </a:rPr>
+              <a:t>break,continue</a:t>
+            </a:r>
+            <a:r>
+              <a:rPr lang="en-US" altLang="ko-KR" sz="2000" dirty="0">
+                <a:latin typeface="Pretendard Light" panose="02000403000000020004" pitchFamily="2" charset="-127"/>
+                <a:ea typeface="Pretendard Light" panose="02000403000000020004" pitchFamily="2" charset="-127"/>
+                <a:cs typeface="Pretendard Light" panose="02000403000000020004" pitchFamily="2" charset="-127"/>
+              </a:rPr>
+              <a:t> </a:t>
+            </a:r>
+            <a:r>
+              <a:rPr lang="ko-KR" altLang="en-US" sz="2000" dirty="0">
+                <a:latin typeface="Pretendard Light" panose="02000403000000020004" pitchFamily="2" charset="-127"/>
+                <a:ea typeface="Pretendard Light" panose="02000403000000020004" pitchFamily="2" charset="-127"/>
+                <a:cs typeface="Pretendard Light" panose="02000403000000020004" pitchFamily="2" charset="-127"/>
+              </a:rPr>
+              <a:t>사용할 것</a:t>
+            </a:r>
+            <a:endParaRPr lang="en-US" altLang="ko-KR" sz="2000" dirty="0">
+              <a:latin typeface="Pretendard Light" panose="02000403000000020004" pitchFamily="2" charset="-127"/>
+              <a:ea typeface="Pretendard Light" panose="02000403000000020004" pitchFamily="2" charset="-127"/>
+              <a:cs typeface="Pretendard Light" panose="02000403000000020004" pitchFamily="2" charset="-127"/>
+            </a:endParaRPr>
+          </a:p>
+          <a:p>
+            <a:r>
+              <a:rPr lang="ko-KR" altLang="en-US" sz="2000" dirty="0">
+                <a:latin typeface="Pretendard Light" panose="02000403000000020004" pitchFamily="2" charset="-127"/>
+                <a:ea typeface="Pretendard Light" panose="02000403000000020004" pitchFamily="2" charset="-127"/>
+                <a:cs typeface="Pretendard Light" panose="02000403000000020004" pitchFamily="2" charset="-127"/>
+              </a:rPr>
+              <a:t>실행 화면과 같은 모습으로 만들어주세요</a:t>
+            </a:r>
+            <a:endParaRPr lang="en-US" altLang="ko-KR" sz="2000" dirty="0">
+              <a:latin typeface="Pretendard Light" panose="02000403000000020004" pitchFamily="2" charset="-127"/>
+              <a:ea typeface="Pretendard Light" panose="02000403000000020004" pitchFamily="2" charset="-127"/>
+              <a:cs typeface="Pretendard Light" panose="02000403000000020004" pitchFamily="2" charset="-127"/>
+            </a:endParaRPr>
+          </a:p>
+        </p:txBody>
+      </p:sp>
+      <p:sp>
+        <p:nvSpPr>
+          <p:cNvPr id="4" name="날짜 개체 틀 3">
+            <a:extLst>
+              <a:ext uri="{FF2B5EF4-FFF2-40B4-BE49-F238E27FC236}">
+                <a16:creationId xmlns:a16="http://schemas.microsoft.com/office/drawing/2014/main" id="{7F53E578-1040-59B0-415A-22DEEDB42199}"/>
+              </a:ext>
+            </a:extLst>
+          </p:cNvPr>
+          <p:cNvSpPr>
+            <a:spLocks noGrp="1"/>
+          </p:cNvSpPr>
+          <p:nvPr>
+            <p:ph type="dt" sz="half" idx="10"/>
+          </p:nvPr>
+        </p:nvSpPr>
+        <p:spPr/>
+        <p:txBody>
+          <a:bodyPr/>
+          <a:lstStyle/>
+          <a:p>
+            <a:fld id="{76022175-F16A-4A96-8E45-178BE9345AE9}" type="datetime6">
+              <a:rPr lang="ko-KR" altLang="en-US" smtClean="0"/>
+              <a:t>2025년 11월</a:t>
+            </a:fld>
+            <a:endParaRPr lang="ko-KR" altLang="en-US"/>
+          </a:p>
+        </p:txBody>
+      </p:sp>
+      <p:sp>
+        <p:nvSpPr>
+          <p:cNvPr id="5" name="슬라이드 번호 개체 틀 4">
+            <a:extLst>
+              <a:ext uri="{FF2B5EF4-FFF2-40B4-BE49-F238E27FC236}">
+                <a16:creationId xmlns:a16="http://schemas.microsoft.com/office/drawing/2014/main" id="{6545AB4A-0989-62D5-E9AD-6B8181BD23DA}"/>
+              </a:ext>
+            </a:extLst>
+          </p:cNvPr>
+          <p:cNvSpPr>
+            <a:spLocks noGrp="1"/>
+          </p:cNvSpPr>
+          <p:nvPr>
+            <p:ph type="sldNum" sz="quarter" idx="12"/>
+          </p:nvPr>
+        </p:nvSpPr>
+        <p:spPr/>
+        <p:txBody>
+          <a:bodyPr/>
+          <a:lstStyle/>
+          <a:p>
+            <a:fld id="{083A2CE0-18CD-4102-B738-4ACFF9E68BA4}" type="slidenum">
+              <a:rPr lang="ko-KR" altLang="en-US" smtClean="0"/>
+              <a:t>26</a:t>
+            </a:fld>
+            <a:endParaRPr lang="ko-KR" altLang="en-US" dirty="0"/>
+          </a:p>
+        </p:txBody>
+      </p:sp>
+      <p:sp>
+        <p:nvSpPr>
+          <p:cNvPr id="3" name="제목 1">
+            <a:extLst>
+              <a:ext uri="{FF2B5EF4-FFF2-40B4-BE49-F238E27FC236}">
+                <a16:creationId xmlns:a16="http://schemas.microsoft.com/office/drawing/2014/main" id="{DDBDA3DF-5437-4874-E6DB-BFE8C91AB995}"/>
+              </a:ext>
+            </a:extLst>
+          </p:cNvPr>
+          <p:cNvSpPr txBox="1">
+            <a:spLocks/>
+          </p:cNvSpPr>
+          <p:nvPr/>
+        </p:nvSpPr>
+        <p:spPr>
+          <a:xfrm>
+            <a:off x="251788" y="1"/>
+            <a:ext cx="10515600" cy="1145406"/>
+          </a:xfrm>
+          <a:prstGeom prst="rect">
+            <a:avLst/>
+          </a:prstGeom>
+        </p:spPr>
+        <p:txBody>
+          <a:bodyPr vert="horz" lIns="91440" tIns="45720" rIns="91440" bIns="45720" rtlCol="0" anchor="ctr">
+            <a:normAutofit/>
+          </a:bodyPr>
+          <a:lstStyle>
+            <a:lvl1pPr algn="l" defTabSz="914400" rtl="0" eaLnBrk="1" latinLnBrk="1" hangingPunct="1">
+              <a:lnSpc>
+                <a:spcPct val="90000"/>
+              </a:lnSpc>
+              <a:spcBef>
+                <a:spcPct val="0"/>
+              </a:spcBef>
+              <a:buNone/>
+              <a:defRPr sz="4800" kern="1200">
+                <a:solidFill>
+                  <a:schemeClr val="tx1"/>
+                </a:solidFill>
+                <a:latin typeface="Pretendard Black" panose="02000A03000000020004" pitchFamily="2" charset="-127"/>
+                <a:ea typeface="Pretendard Black" panose="02000A03000000020004" pitchFamily="2" charset="-127"/>
+                <a:cs typeface="Pretendard Black" panose="02000A03000000020004" pitchFamily="2" charset="-127"/>
+              </a:defRPr>
+            </a:lvl1pPr>
+          </a:lstStyle>
+          <a:p>
+            <a:r>
+              <a:rPr lang="ko-KR" altLang="en-US">
+                <a:solidFill>
+                  <a:srgbClr val="ED7D31"/>
+                </a:solidFill>
+              </a:rPr>
+              <a:t>실습</a:t>
+            </a:r>
+            <a:r>
+              <a:rPr lang="en-US" altLang="ko-KR">
+                <a:solidFill>
+                  <a:srgbClr val="ED7D31"/>
+                </a:solidFill>
+              </a:rPr>
+              <a:t>3. </a:t>
+            </a:r>
+            <a:r>
+              <a:rPr lang="ko-KR" altLang="en-US">
+                <a:solidFill>
+                  <a:srgbClr val="ED7D31"/>
+                </a:solidFill>
+              </a:rPr>
+              <a:t>중첩 </a:t>
+            </a:r>
+            <a:r>
+              <a:rPr lang="en-US" altLang="ko-KR">
+                <a:solidFill>
+                  <a:srgbClr val="ED7D31"/>
+                </a:solidFill>
+              </a:rPr>
+              <a:t>while</a:t>
+            </a:r>
+            <a:r>
+              <a:rPr lang="ko-KR" altLang="en-US">
+                <a:solidFill>
+                  <a:srgbClr val="ED7D31"/>
+                </a:solidFill>
+              </a:rPr>
+              <a:t>문 연습문제</a:t>
+            </a:r>
+            <a:endParaRPr lang="ko-KR" altLang="en-US" dirty="0">
+              <a:solidFill>
+                <a:srgbClr val="ED7D31"/>
+              </a:solidFill>
+            </a:endParaRPr>
+          </a:p>
+        </p:txBody>
+      </p:sp>
+      <p:pic>
+        <p:nvPicPr>
+          <p:cNvPr id="6" name="그림 5">
+            <a:extLst>
+              <a:ext uri="{FF2B5EF4-FFF2-40B4-BE49-F238E27FC236}">
+                <a16:creationId xmlns:a16="http://schemas.microsoft.com/office/drawing/2014/main" id="{326BA4D6-F579-AC0C-063D-1E0293E39081}"/>
+              </a:ext>
+            </a:extLst>
+          </p:cNvPr>
+          <p:cNvPicPr>
+            <a:picLocks noChangeAspect="1"/>
+          </p:cNvPicPr>
+          <p:nvPr/>
+        </p:nvPicPr>
+        <p:blipFill>
+          <a:blip r:embed="rId3"/>
+          <a:srcRect b="47843"/>
+          <a:stretch>
+            <a:fillRect/>
+          </a:stretch>
+        </p:blipFill>
+        <p:spPr>
+          <a:xfrm>
+            <a:off x="5611906" y="1378168"/>
+            <a:ext cx="2432055" cy="4101663"/>
+          </a:xfrm>
+          <a:prstGeom prst="rect">
+            <a:avLst/>
+          </a:prstGeom>
+        </p:spPr>
+      </p:pic>
+      <p:pic>
+        <p:nvPicPr>
+          <p:cNvPr id="9" name="그림 8">
+            <a:extLst>
+              <a:ext uri="{FF2B5EF4-FFF2-40B4-BE49-F238E27FC236}">
+                <a16:creationId xmlns:a16="http://schemas.microsoft.com/office/drawing/2014/main" id="{1B2C1A36-B58D-3E9F-D413-9FEC6BCAFB68}"/>
+              </a:ext>
+            </a:extLst>
+          </p:cNvPr>
+          <p:cNvPicPr>
+            <a:picLocks noChangeAspect="1"/>
+          </p:cNvPicPr>
+          <p:nvPr/>
+        </p:nvPicPr>
+        <p:blipFill>
+          <a:blip r:embed="rId3"/>
+          <a:srcRect t="52157"/>
+          <a:stretch>
+            <a:fillRect/>
+          </a:stretch>
+        </p:blipFill>
+        <p:spPr>
+          <a:xfrm>
+            <a:off x="8283388" y="1403592"/>
+            <a:ext cx="2618471" cy="4050815"/>
+          </a:xfrm>
+          <a:prstGeom prst="rect">
+            <a:avLst/>
+          </a:prstGeom>
+        </p:spPr>
+      </p:pic>
+    </p:spTree>
+    <p:extLst>
+      <p:ext uri="{BB962C8B-B14F-4D97-AF65-F5344CB8AC3E}">
+        <p14:creationId xmlns:p14="http://schemas.microsoft.com/office/powerpoint/2010/main" val="2491849634"/>
+      </p:ext>
+    </p:extLst>
+  </p:cSld>
+  <p:clrMapOvr>
+    <a:masterClrMapping/>
+  </p:clrMapOvr>
+</p:sld>
+</file>
+
+<file path=ppt/slides/slide27.xml><?xml version="1.0" encoding="utf-8"?>
 <p:sld xmlns:a="http://schemas.openxmlformats.org/drawingml/2006/main" xmlns:r="http://schemas.openxmlformats.org/officeDocument/2006/relationships" xmlns:p="http://schemas.openxmlformats.org/presentationml/2006/main">
   <p:cSld>
     <p:spTree>
@@ -11223,7 +11800,7 @@
           <a:p>
             <a:fld id="{0F78D9C4-20C1-4B15-A116-16DC77AD9A1E}" type="datetime1">
               <a:rPr lang="ko-KR" altLang="en-US" smtClean="0"/>
-              <a:t>2025-09-01</a:t>
+              <a:t>2025-11-19</a:t>
             </a:fld>
             <a:endParaRPr lang="ko-KR" altLang="en-US" dirty="0"/>
           </a:p>
@@ -11780,7 +12357,7 @@
           <a:p>
             <a:fld id="{0F78D9C4-20C1-4B15-A116-16DC77AD9A1E}" type="datetime1">
               <a:rPr lang="ko-KR" altLang="en-US" smtClean="0"/>
-              <a:t>2025-09-01</a:t>
+              <a:t>2025-11-19</a:t>
             </a:fld>
             <a:endParaRPr lang="ko-KR" altLang="en-US" dirty="0"/>
           </a:p>
@@ -12240,7 +12817,7 @@
           <a:p>
             <a:fld id="{0F78D9C4-20C1-4B15-A116-16DC77AD9A1E}" type="datetime1">
               <a:rPr lang="ko-KR" altLang="en-US" smtClean="0"/>
-              <a:t>2025-09-01</a:t>
+              <a:t>2025-11-19</a:t>
             </a:fld>
             <a:endParaRPr lang="ko-KR" altLang="en-US" dirty="0"/>
           </a:p>
@@ -13703,7 +14280,7 @@
           <a:p>
             <a:fld id="{0F78D9C4-20C1-4B15-A116-16DC77AD9A1E}" type="datetime1">
               <a:rPr lang="ko-KR" altLang="en-US" smtClean="0"/>
-              <a:t>2025-09-01</a:t>
+              <a:t>2025-11-19</a:t>
             </a:fld>
             <a:endParaRPr lang="ko-KR" altLang="en-US" dirty="0"/>
           </a:p>
@@ -14268,7 +14845,7 @@
           <a:p>
             <a:fld id="{0F78D9C4-20C1-4B15-A116-16DC77AD9A1E}" type="datetime1">
               <a:rPr lang="ko-KR" altLang="en-US" smtClean="0"/>
-              <a:t>2025-09-01</a:t>
+              <a:t>2025-11-19</a:t>
             </a:fld>
             <a:endParaRPr lang="ko-KR" altLang="en-US"/>
           </a:p>

</xml_diff>